<commit_message>
Personnalise les courriers ATLI Worldwide et CIE-SODECI, complète les exports PDF des packs
- ATLI Worldwide : courrier adressé à Monsieur Benoît Bindè Bindè, Directeur Général
- CIE-SODECI : fusionne les 2 courriers séparés en un seul, adressé à Monsieur Gnamian N'Guetta Abdoulaye, Directeur Production Informatique
- Ajoute les exports PDF manquants pour AHK CI, BNI, Pigier CI, Port Autonome San Pedro
- Ajoute une version alternative de la Charte IA (script Python) dans outputs/

Co-Authored-By: Claude Sonnet 5 <noreply@anthropic.com>
</commit_message>
<xml_diff>
--- a/docs/transferai-prospection/packs-entreprises-cibles-2026-07/AHK_CI/Deck_AHK_CI_2026-07-07.pptx
+++ b/docs/transferai-prospection/packs-entreprises-cibles-2026-07/AHK_CI/Deck_AHK_CI_2026-07-07.pptx
@@ -1791,7 +1791,7 @@
                 <a:ea typeface="Arial" pitchFamily="34" charset="-122"/>
                 <a:cs typeface="Arial" pitchFamily="34" charset="-120"/>
               </a:rPr>
-              <a:t>Faire de l'IA un levier de veille et de coordination bilingue pour la Délégation de l'Économie Allemande en Côte d'Ivoire</a:t>
+              <a:t>Faire de l'IA un levier de veille et de coordination bilingue pour AHK Côte d'Ivoire</a:t>
             </a:r>
             <a:endParaRPr lang="en-US" sz="3200" dirty="0"/>
           </a:p>
@@ -3153,8 +3153,8 @@
         </p:nvSpPr>
         <p:spPr>
           <a:xfrm>
-            <a:off x="548640" y="6355080"/>
-            <a:ext cx="7315200" cy="320040"/>
+            <a:off x="548640" y="6035040"/>
+            <a:ext cx="7315200" cy="274320"/>
           </a:xfrm>
           <a:prstGeom prst="rect">
             <a:avLst/>

</xml_diff>